<commit_message>
Regenerate PPTX with backup slide, fix output path
Co-Authored-By: Claude Opus 4.6 <noreply@anthropic.com>
</commit_message>
<xml_diff>
--- a/deck.pptx
+++ b/deck.pptx
@@ -22,6 +22,7 @@
     <p:sldId id="270" r:id="rId21"/>
     <p:sldId id="271" r:id="rId22"/>
     <p:sldId id="272" r:id="rId23"/>
+    <p:sldId id="273" r:id="rId24"/>
   </p:sldIdLst>
   <p:sldSz cx="12191695" cy="6858000" type="screen4x3"/>
   <p:notesSz cx="6858000" cy="9144000"/>
@@ -5270,6 +5271,368 @@
 </file>
 
 <file path=ppt/slides/slide17.xml><?xml version="1.0" encoding="utf-8"?>
+<p:sld xmlns:a="http://schemas.openxmlformats.org/drawingml/2006/main" xmlns:p="http://schemas.openxmlformats.org/presentationml/2006/main" xmlns:r="http://schemas.openxmlformats.org/officeDocument/2006/relationships">
+  <p:cSld>
+    <p:bg>
+      <p:bgPr>
+        <a:solidFill>
+          <a:srgbClr val="1A1A2E"/>
+        </a:solidFill>
+        <a:effectLst/>
+      </p:bgPr>
+    </p:bg>
+    <p:spTree>
+      <p:nvGrpSpPr>
+        <p:cNvPr id="1" name=""/>
+        <p:cNvGrpSpPr/>
+        <p:nvPr/>
+      </p:nvGrpSpPr>
+      <p:grpSpPr/>
+      <p:sp>
+        <p:nvSpPr>
+          <p:cNvPr id="2" name="TextBox 1"/>
+          <p:cNvSpPr txBox="1"/>
+          <p:nvPr/>
+        </p:nvSpPr>
+        <p:spPr>
+          <a:xfrm>
+            <a:off x="731520" y="365760"/>
+            <a:ext cx="10058400" cy="914400"/>
+          </a:xfrm>
+          <a:prstGeom prst="rect">
+            <a:avLst/>
+          </a:prstGeom>
+          <a:noFill/>
+        </p:spPr>
+        <p:txBody>
+          <a:bodyPr wrap="none">
+            <a:spAutoFit/>
+          </a:bodyPr>
+          <a:lstStyle/>
+          <a:p>
+            <a:r>
+              <a:rPr sz="3600" b="1" i="0">
+                <a:solidFill>
+                  <a:srgbClr val="00D4FF"/>
+                </a:solidFill>
+                <a:latin typeface="Helvetica Neue"/>
+              </a:rPr>
+              <a:t>Why Knowledge Graphs Stay Niche</a:t>
+            </a:r>
+          </a:p>
+        </p:txBody>
+      </p:sp>
+      <p:graphicFrame>
+        <p:nvGraphicFramePr>
+          <p:cNvPr id="3" name="Table 2"/>
+          <p:cNvGraphicFramePr>
+            <a:graphicFrameLocks noGrp="1"/>
+          </p:cNvGraphicFramePr>
+          <p:nvPr/>
+        </p:nvGraphicFramePr>
+        <p:xfrm>
+          <a:off x="731520" y="1463040"/>
+          <a:ext cx="10515600" cy="2103120"/>
+        </p:xfrm>
+        <a:graphic>
+          <a:graphicData uri="http://schemas.openxmlformats.org/drawingml/2006/table">
+            <a:tbl>
+              <a:tblPr firstRow="1" bandRow="1">
+                <a:tableStyleId>{5C22544A-7EE6-4342-B048-85BDC9FD1C3A}</a:tableStyleId>
+              </a:tblPr>
+              <a:tblGrid>
+                <a:gridCol w="3505200"/>
+                <a:gridCol w="3505200"/>
+                <a:gridCol w="3505200"/>
+              </a:tblGrid>
+              <a:tr h="525780">
+                <a:tc>
+                  <a:txBody>
+                    <a:bodyPr/>
+                    <a:lstStyle/>
+                    <a:p>
+                      <a:pPr algn="ctr"/>
+                      <a:r>
+                        <a:rPr sz="1600" b="1" i="0">
+                          <a:solidFill>
+                            <a:srgbClr val="00D4FF"/>
+                          </a:solidFill>
+                          <a:latin typeface="Helvetica Neue"/>
+                        </a:rPr>
+                        <a:t>Knowledge type</a:t>
+                      </a:r>
+                    </a:p>
+                  </a:txBody>
+                  <a:tcPr>
+                    <a:solidFill>
+                      <a:srgbClr val="16213E"/>
+                    </a:solidFill>
+                  </a:tcPr>
+                </a:tc>
+                <a:tc>
+                  <a:txBody>
+                    <a:bodyPr/>
+                    <a:lstStyle/>
+                    <a:p>
+                      <a:pPr algn="ctr"/>
+                      <a:r>
+                        <a:rPr sz="1600" b="1" i="0">
+                          <a:solidFill>
+                            <a:srgbClr val="00D4FF"/>
+                          </a:solidFill>
+                          <a:latin typeface="Helvetica Neue"/>
+                        </a:rPr>
+                        <a:t>Example</a:t>
+                      </a:r>
+                    </a:p>
+                  </a:txBody>
+                  <a:tcPr>
+                    <a:solidFill>
+                      <a:srgbClr val="16213E"/>
+                    </a:solidFill>
+                  </a:tcPr>
+                </a:tc>
+                <a:tc>
+                  <a:txBody>
+                    <a:bodyPr/>
+                    <a:lstStyle/>
+                    <a:p>
+                      <a:pPr algn="ctr"/>
+                      <a:r>
+                        <a:rPr sz="1600" b="1" i="0">
+                          <a:solidFill>
+                            <a:srgbClr val="00D4FF"/>
+                          </a:solidFill>
+                          <a:latin typeface="Helvetica Neue"/>
+                        </a:rPr>
+                        <a:t>Best home</a:t>
+                      </a:r>
+                    </a:p>
+                  </a:txBody>
+                  <a:tcPr>
+                    <a:solidFill>
+                      <a:srgbClr val="16213E"/>
+                    </a:solidFill>
+                  </a:tcPr>
+                </a:tc>
+              </a:tr>
+              <a:tr h="525780">
+                <a:tc>
+                  <a:txBody>
+                    <a:bodyPr/>
+                    <a:lstStyle/>
+                    <a:p>
+                      <a:r>
+                        <a:rPr sz="1400" b="0" i="0">
+                          <a:solidFill>
+                            <a:srgbClr val="E0E0E0"/>
+                          </a:solidFill>
+                          <a:latin typeface="Helvetica Neue"/>
+                        </a:rPr>
+                        <a:t>General knowledge</a:t>
+                      </a:r>
+                    </a:p>
+                  </a:txBody>
+                  <a:tcPr>
+                    <a:solidFill>
+                      <a:srgbClr val="0F3460"/>
+                    </a:solidFill>
+                  </a:tcPr>
+                </a:tc>
+                <a:tc>
+                  <a:txBody>
+                    <a:bodyPr/>
+                    <a:lstStyle/>
+                    <a:p>
+                      <a:r>
+                        <a:rPr sz="1400" b="0" i="0">
+                          <a:solidFill>
+                            <a:srgbClr val="E0E0E0"/>
+                          </a:solidFill>
+                          <a:latin typeface="Helvetica Neue"/>
+                        </a:rPr>
+                        <a:t>"Water is wet except when it's ice"</a:t>
+                      </a:r>
+                    </a:p>
+                  </a:txBody>
+                  <a:tcPr>
+                    <a:solidFill>
+                      <a:srgbClr val="0F3460"/>
+                    </a:solidFill>
+                  </a:tcPr>
+                </a:tc>
+                <a:tc>
+                  <a:txBody>
+                    <a:bodyPr/>
+                    <a:lstStyle/>
+                    <a:p>
+                      <a:r>
+                        <a:rPr sz="1400" b="0" i="0">
+                          <a:solidFill>
+                            <a:srgbClr val="E0E0E0"/>
+                          </a:solidFill>
+                          <a:latin typeface="Helvetica Neue"/>
+                        </a:rPr>
+                        <a:t>LLMs just know this</a:t>
+                      </a:r>
+                    </a:p>
+                  </a:txBody>
+                  <a:tcPr>
+                    <a:solidFill>
+                      <a:srgbClr val="0F3460"/>
+                    </a:solidFill>
+                  </a:tcPr>
+                </a:tc>
+              </a:tr>
+              <a:tr h="525780">
+                <a:tc>
+                  <a:txBody>
+                    <a:bodyPr/>
+                    <a:lstStyle/>
+                    <a:p>
+                      <a:r>
+                        <a:rPr sz="1400" b="0" i="0">
+                          <a:solidFill>
+                            <a:srgbClr val="E0E0E0"/>
+                          </a:solidFill>
+                          <a:latin typeface="Helvetica Neue"/>
+                        </a:rPr>
+                        <a:t>Business facts</a:t>
+                      </a:r>
+                    </a:p>
+                  </a:txBody>
+                  <a:tcPr>
+                    <a:solidFill>
+                      <a:srgbClr val="0F3460"/>
+                    </a:solidFill>
+                  </a:tcPr>
+                </a:tc>
+                <a:tc>
+                  <a:txBody>
+                    <a:bodyPr/>
+                    <a:lstStyle/>
+                    <a:p>
+                      <a:r>
+                        <a:rPr sz="1400" b="0" i="0">
+                          <a:solidFill>
+                            <a:srgbClr val="E0E0E0"/>
+                          </a:solidFill>
+                          <a:latin typeface="Helvetica Neue"/>
+                        </a:rPr>
+                        <a:t>"John bought apples on Tuesday"</a:t>
+                      </a:r>
+                    </a:p>
+                  </a:txBody>
+                  <a:tcPr>
+                    <a:solidFill>
+                      <a:srgbClr val="0F3460"/>
+                    </a:solidFill>
+                  </a:tcPr>
+                </a:tc>
+                <a:tc>
+                  <a:txBody>
+                    <a:bodyPr/>
+                    <a:lstStyle/>
+                    <a:p>
+                      <a:r>
+                        <a:rPr sz="1400" b="0" i="0">
+                          <a:solidFill>
+                            <a:srgbClr val="E0E0E0"/>
+                          </a:solidFill>
+                          <a:latin typeface="Helvetica Neue"/>
+                        </a:rPr>
+                        <a:t>SQL databases + semantic layer</a:t>
+                      </a:r>
+                    </a:p>
+                  </a:txBody>
+                  <a:tcPr>
+                    <a:solidFill>
+                      <a:srgbClr val="0F3460"/>
+                    </a:solidFill>
+                  </a:tcPr>
+                </a:tc>
+              </a:tr>
+              <a:tr h="525780">
+                <a:tc>
+                  <a:txBody>
+                    <a:bodyPr/>
+                    <a:lstStyle/>
+                    <a:p>
+                      <a:r>
+                        <a:rPr sz="1400" b="0" i="0">
+                          <a:solidFill>
+                            <a:srgbClr val="E0E0E0"/>
+                          </a:solidFill>
+                          <a:latin typeface="Helvetica Neue"/>
+                        </a:rPr>
+                        <a:t>Graph-structured problems</a:t>
+                      </a:r>
+                    </a:p>
+                  </a:txBody>
+                  <a:tcPr>
+                    <a:solidFill>
+                      <a:srgbClr val="0F3460"/>
+                    </a:solidFill>
+                  </a:tcPr>
+                </a:tc>
+                <a:tc>
+                  <a:txBody>
+                    <a:bodyPr/>
+                    <a:lstStyle/>
+                    <a:p>
+                      <a:r>
+                        <a:rPr sz="1400" b="0" i="0">
+                          <a:solidFill>
+                            <a:srgbClr val="E0E0E0"/>
+                          </a:solidFill>
+                          <a:latin typeface="Helvetica Neue"/>
+                        </a:rPr>
+                        <a:t>Fraud rings, network routing</a:t>
+                      </a:r>
+                    </a:p>
+                  </a:txBody>
+                  <a:tcPr>
+                    <a:solidFill>
+                      <a:srgbClr val="0F3460"/>
+                    </a:solidFill>
+                  </a:tcPr>
+                </a:tc>
+                <a:tc>
+                  <a:txBody>
+                    <a:bodyPr/>
+                    <a:lstStyle/>
+                    <a:p>
+                      <a:r>
+                        <a:rPr sz="1400" b="0" i="0">
+                          <a:solidFill>
+                            <a:srgbClr val="E0E0E0"/>
+                          </a:solidFill>
+                          <a:latin typeface="Helvetica Neue"/>
+                        </a:rPr>
+                        <a:t>Bespoke software</a:t>
+                      </a:r>
+                    </a:p>
+                  </a:txBody>
+                  <a:tcPr>
+                    <a:solidFill>
+                      <a:srgbClr val="0F3460"/>
+                    </a:solidFill>
+                  </a:tcPr>
+                </a:tc>
+              </a:tr>
+            </a:tbl>
+          </a:graphicData>
+        </a:graphic>
+      </p:graphicFrame>
+    </p:spTree>
+  </p:cSld>
+  <p:clrMapOvr>
+    <a:masterClrMapping/>
+  </p:clrMapOvr>
+</p:sld>
+</file>
+
+<file path=ppt/slides/slide18.xml><?xml version="1.0" encoding="utf-8"?>
 <p:sld xmlns:a="http://schemas.openxmlformats.org/drawingml/2006/main" xmlns:p="http://schemas.openxmlformats.org/presentationml/2006/main" xmlns:r="http://schemas.openxmlformats.org/officeDocument/2006/relationships">
   <p:cSld>
     <p:bg>

</xml_diff>